<commit_message>
docs: README, auditoría y diapositivas coherentes con el informe
</commit_message>
<xml_diff>
--- a/presentacion/breastdcedl_diapositivas.pptx
+++ b/presentacion/breastdcedl_diapositivas.pptx
@@ -1721,7 +1721,7 @@
           </a:p>
           <a:p>
             <a:r>
-              <a:t>- Inicialización: la de PyTorch, Kaiming uniforme; BatchNorm con peso 1 y sesgo 0.</a:t>
+              <a:t>- Inicialización: la de PyTorch por defecto: en convoluciones y lineales, pesos uniformes en ±1/√(entradas) (kaiming_uniform_ con a = √5); BatchNorm con peso 1 y sesgo 0. Con BatchNorm tras cada convolución, la escala inicial importa poco.</a:t>
             </a:r>
           </a:p>
           <a:p>
@@ -1816,7 +1816,7 @@
           </a:p>
           <a:p>
             <a:r>
-              <a:t>Resultados: la CNN da 0,554 ± 0,043 en validación cruzada (interna, y algo optimista porque las versiones, las 6 épocas, Platt y el umbral salieron de esos folds), al nivel de saber solo la cohorte. En test, con pacientes nuevas y mirado una sola vez, da 0,540 (IC 0,45–0,63): cuadra con la validación, pero no se distingue del azar. El médico, con edad, menopausia, HR y HER2, llega a 0,689 y 0,664; en test, su ventaja sobre la CNN tiene un intervalo que roza el 0 (−0,259 a +0,009). Sumarle la imagen no añade nada demostrable. Con el umbral, la CNN detecta 10 de 53 pCR en test; el médico, 21.</a:t>
+              <a:t>Resultados: la CNN da 0,554 ± 0,043 en validación cruzada (interna, y algo optimista porque las versiones, las 6 épocas, Platt y el umbral salieron de esos folds), al nivel de saber solo la cohorte. En test, con pacientes nuevas y mirado una sola vez, da 0,540 (IC 0,45–0,63): cuadra con la validación, pero no se distingue del azar. El médico, con edad, menopausia, HR y HER2, llega a 0,689 y 0,664; en test, la CNN queda 0,125 por debajo del médico, con un intervalo que roza el 0 (CNN − médico: −0,259 a +0,009). Sumarle la imagen no añade nada demostrable. Con el umbral, la CNN detecta 10 de 53 pCR en test; el médico, 21.</a:t>
             </a:r>
           </a:p>
           <a:p>

</xml_diff>